<commit_message>
Stage 8 review fixes: B-033
</commit_message>
<xml_diff>
--- a/output/archive/Archive/Users/mellerscombe_old_laptop/Studies/BW18_0225/BW18_0225_hERG_CLIENT_v3_FINAL_final.pptx
+++ b/output/archive/Archive/Users/mellerscombe_old_laptop/Studies/BW18_0225/BW18_0225_hERG_CLIENT_v3_FINAL_final.pptx
@@ -650,7 +650,7 @@
           <a:lstStyle/>
           <a:p>
             <a:r>
-              <a:t>Full 32-row table is in the released report. This slide only shows the first block.</a:t>
+              <a:t>Full compound table is in the released report. Retain accepted-cell counts and censoring qualifications alongside the estimates.</a:t>
             </a:r>
           </a:p>
         </p:txBody>
@@ -720,7 +720,7 @@
           <a:lstStyle/>
           <a:p>
             <a:r>
-              <a:t>Check the censored estimate footnote wording against the released table, not against this slide.</a:t>
+              <a:t>Censored entries are lower bounds at the top tested concentration, not finite IC50 measurements; consult the compound table when comparing bars.</a:t>
             </a:r>
           </a:p>
         </p:txBody>
@@ -746,6 +746,146 @@
 </file>
 
 <file path=ppt/notesSlides/notesSlide5.xml><?xml version="1.0" encoding="utf-8"?>
+<p:notes xmlns:a="http://schemas.openxmlformats.org/drawingml/2006/main" xmlns:p="http://schemas.openxmlformats.org/presentationml/2006/main" xmlns:r="http://schemas.openxmlformats.org/officeDocument/2006/relationships">
+  <p:cSld>
+    <p:spTree>
+      <p:nvGrpSpPr>
+        <p:cNvPr id="1" name=""/>
+        <p:cNvGrpSpPr/>
+        <p:nvPr/>
+      </p:nvGrpSpPr>
+      <p:grpSpPr>
+        <a:xfrm>
+          <a:off x="0" y="0"/>
+          <a:ext cx="0" cy="0"/>
+          <a:chOff x="0" y="0"/>
+          <a:chExt cx="0" cy="0"/>
+        </a:xfrm>
+      </p:grpSpPr>
+      <p:sp>
+        <p:nvSpPr>
+          <p:cNvPr id="2" name="Slide Image Placeholder 1"/>
+          <p:cNvSpPr>
+            <a:spLocks noGrp="1"/>
+          </p:cNvSpPr>
+          <p:nvPr>
+            <p:ph type="sldImg" idx="2"/>
+          </p:nvPr>
+        </p:nvSpPr>
+        <p:spPr/>
+      </p:sp>
+      <p:sp>
+        <p:nvSpPr>
+          <p:cNvPr id="3" name="Notes Placeholder 2"/>
+          <p:cNvSpPr>
+            <a:spLocks noGrp="1"/>
+          </p:cNvSpPr>
+          <p:nvPr>
+            <p:ph type="body" idx="3" sz="quarter"/>
+          </p:nvPr>
+        </p:nvSpPr>
+        <p:spPr/>
+        <p:txBody>
+          <a:bodyPr/>
+          <a:lstStyle/>
+          <a:p>
+            <a:r>
+              <a:t>Check the censored estimate footnote wording against the released table, not against this slide.</a:t>
+            </a:r>
+          </a:p>
+        </p:txBody>
+      </p:sp>
+      <p:sp>
+        <p:nvSpPr>
+          <p:cNvPr id="4" name="Slide Number Placeholder 3"/>
+          <p:cNvSpPr>
+            <a:spLocks noGrp="1"/>
+          </p:cNvSpPr>
+          <p:nvPr>
+            <p:ph type="sldNum" idx="5" sz="quarter"/>
+          </p:nvPr>
+        </p:nvSpPr>
+        <p:spPr/>
+      </p:sp>
+    </p:spTree>
+  </p:cSld>
+  <p:clrMapOvr>
+    <a:masterClrMapping/>
+  </p:clrMapOvr>
+</p:notes>
+</file>
+
+<file path=ppt/notesSlides/notesSlide6.xml><?xml version="1.0" encoding="utf-8"?>
+<p:notes xmlns:a="http://schemas.openxmlformats.org/drawingml/2006/main" xmlns:p="http://schemas.openxmlformats.org/presentationml/2006/main" xmlns:r="http://schemas.openxmlformats.org/officeDocument/2006/relationships">
+  <p:cSld>
+    <p:spTree>
+      <p:nvGrpSpPr>
+        <p:cNvPr id="1" name=""/>
+        <p:cNvGrpSpPr/>
+        <p:nvPr/>
+      </p:nvGrpSpPr>
+      <p:grpSpPr>
+        <a:xfrm>
+          <a:off x="0" y="0"/>
+          <a:ext cx="0" cy="0"/>
+          <a:chOff x="0" y="0"/>
+          <a:chExt cx="0" cy="0"/>
+        </a:xfrm>
+      </p:grpSpPr>
+      <p:sp>
+        <p:nvSpPr>
+          <p:cNvPr id="2" name="Slide Image Placeholder 1"/>
+          <p:cNvSpPr>
+            <a:spLocks noGrp="1"/>
+          </p:cNvSpPr>
+          <p:nvPr>
+            <p:ph type="sldImg" idx="2"/>
+          </p:nvPr>
+        </p:nvSpPr>
+        <p:spPr/>
+      </p:sp>
+      <p:sp>
+        <p:nvSpPr>
+          <p:cNvPr id="3" name="Notes Placeholder 2"/>
+          <p:cNvSpPr>
+            <a:spLocks noGrp="1"/>
+          </p:cNvSpPr>
+          <p:nvPr>
+            <p:ph type="body" idx="3" sz="quarter"/>
+          </p:nvPr>
+        </p:nvSpPr>
+        <p:spPr/>
+        <p:txBody>
+          <a:bodyPr/>
+          <a:lstStyle/>
+          <a:p>
+            <a:r>
+              <a:t>Quote dated 06 Jun 2018; study started 06 Jul 2018; interim dated 16 Jul 2018; completion 23 Jul 2018. Turnaround 17 calendar days. Structures illustrate the screening set; they do not identify a causal substituent by themselves.</a:t>
+            </a:r>
+          </a:p>
+        </p:txBody>
+      </p:sp>
+      <p:sp>
+        <p:nvSpPr>
+          <p:cNvPr id="4" name="Slide Number Placeholder 3"/>
+          <p:cNvSpPr>
+            <a:spLocks noGrp="1"/>
+          </p:cNvSpPr>
+          <p:nvPr>
+            <p:ph type="sldNum" idx="5" sz="quarter"/>
+          </p:nvPr>
+        </p:nvSpPr>
+        <p:spPr/>
+      </p:sp>
+    </p:spTree>
+  </p:cSld>
+  <p:clrMapOvr>
+    <a:masterClrMapping/>
+  </p:clrMapOvr>
+</p:notes>
+</file>
+
+<file path=ppt/notesSlides/notesSlide7.xml><?xml version="1.0" encoding="utf-8"?>
 <p:notes xmlns:a="http://schemas.openxmlformats.org/drawingml/2006/main" xmlns:p="http://schemas.openxmlformats.org/presentationml/2006/main" xmlns:r="http://schemas.openxmlformats.org/officeDocument/2006/relationships">
   <p:cSld>
     <p:spTree>
@@ -3898,7 +4038,7 @@
                 </a:solidFill>
                 <a:latin typeface="Times New Roman"/>
               </a:rPr>
-              <a:t>Readout | BW18_0225 | Feldorune Therapeutics BV</a:t>
+              <a:t>Readout | BW18_0225 | Feldorune Therapeutics BV | Brindlewythe Biosciences Ltd</a:t>
             </a:r>
           </a:p>
         </p:txBody>
@@ -4796,12 +4936,14 @@
                 <a:tableStyleId>{5C22544A-7EE6-4342-B048-85BDC9FD1C3A}</a:tableStyleId>
               </a:tblPr>
               <a:tblGrid>
-                <a:gridCol w="1879549"/>
-                <a:gridCol w="1879549"/>
-                <a:gridCol w="1879549"/>
-                <a:gridCol w="1879549"/>
-                <a:gridCol w="1879549"/>
-                <a:gridCol w="1879550"/>
+                <a:gridCol w="1409661"/>
+                <a:gridCol w="1409661"/>
+                <a:gridCol w="1409661"/>
+                <a:gridCol w="1409661"/>
+                <a:gridCol w="1409661"/>
+                <a:gridCol w="1409661"/>
+                <a:gridCol w="1409661"/>
+                <a:gridCol w="1409668"/>
               </a:tblGrid>
               <a:tr h="274320">
                 <a:tc>
@@ -4810,7 +4952,7 @@
                     <a:lstStyle/>
                     <a:p>
                       <a:r>
-                        <a:rPr sz="1200" b="1">
+                        <a:rPr sz="1100" b="1">
                           <a:solidFill>
                             <a:srgbClr val="FFFFFF"/>
                           </a:solidFill>
@@ -4832,7 +4974,7 @@
                     <a:lstStyle/>
                     <a:p>
                       <a:r>
-                        <a:rPr sz="1200" b="1">
+                        <a:rPr sz="1100" b="1">
                           <a:solidFill>
                             <a:srgbClr val="FFFFFF"/>
                           </a:solidFill>
@@ -4854,7 +4996,7 @@
                     <a:lstStyle/>
                     <a:p>
                       <a:r>
-                        <a:rPr sz="1200" b="1">
+                        <a:rPr sz="1100" b="1">
                           <a:solidFill>
                             <a:srgbClr val="FFFFFF"/>
                           </a:solidFill>
@@ -4876,7 +5018,7 @@
                     <a:lstStyle/>
                     <a:p>
                       <a:r>
-                        <a:rPr sz="1200" b="1">
+                        <a:rPr sz="1100" b="1">
                           <a:solidFill>
                             <a:srgbClr val="FFFFFF"/>
                           </a:solidFill>
@@ -4898,7 +5040,7 @@
                     <a:lstStyle/>
                     <a:p>
                       <a:r>
-                        <a:rPr sz="1200" b="1">
+                        <a:rPr sz="1100" b="1">
                           <a:solidFill>
                             <a:srgbClr val="FFFFFF"/>
                           </a:solidFill>
@@ -4920,7 +5062,7 @@
                     <a:lstStyle/>
                     <a:p>
                       <a:r>
-                        <a:rPr sz="1200" b="1">
+                        <a:rPr sz="1100" b="1">
                           <a:solidFill>
                             <a:srgbClr val="FFFFFF"/>
                           </a:solidFill>
@@ -4936,6 +5078,50 @@
                     </a:solidFill>
                   </a:tcPr>
                 </a:tc>
+                <a:tc>
+                  <a:txBody>
+                    <a:bodyPr/>
+                    <a:lstStyle/>
+                    <a:p>
+                      <a:r>
+                        <a:rPr sz="1100" b="1">
+                          <a:solidFill>
+                            <a:srgbClr val="FFFFFF"/>
+                          </a:solidFill>
+                          <a:latin typeface="Times New Roman"/>
+                        </a:rPr>
+                        <a:t>n cells (finite)</a:t>
+                      </a:r>
+                    </a:p>
+                  </a:txBody>
+                  <a:tcPr>
+                    <a:solidFill>
+                      <a:srgbClr val="683C57"/>
+                    </a:solidFill>
+                  </a:tcPr>
+                </a:tc>
+                <a:tc>
+                  <a:txBody>
+                    <a:bodyPr/>
+                    <a:lstStyle/>
+                    <a:p>
+                      <a:r>
+                        <a:rPr sz="1100" b="1">
+                          <a:solidFill>
+                            <a:srgbClr val="FFFFFF"/>
+                          </a:solidFill>
+                          <a:latin typeface="Times New Roman"/>
+                        </a:rPr>
+                        <a:t>QC note</a:t>
+                      </a:r>
+                    </a:p>
+                  </a:txBody>
+                  <a:tcPr>
+                    <a:solidFill>
+                      <a:srgbClr val="683C57"/>
+                    </a:solidFill>
+                  </a:tcPr>
+                </a:tc>
               </a:tr>
               <a:tr h="274320">
                 <a:tc>
@@ -4944,7 +5130,7 @@
                     <a:lstStyle/>
                     <a:p>
                       <a:r>
-                        <a:rPr sz="1200">
+                        <a:rPr sz="1100">
                           <a:latin typeface="Times New Roman"/>
                         </a:rPr>
                         <a:t>FT09-07000</a:t>
@@ -4959,7 +5145,7 @@
                     <a:lstStyle/>
                     <a:p>
                       <a:r>
-                        <a:rPr sz="1200">
+                        <a:rPr sz="1100">
                           <a:latin typeface="Times New Roman"/>
                         </a:rPr>
                         <a:t>22</a:t>
@@ -4974,7 +5160,7 @@
                     <a:lstStyle/>
                     <a:p>
                       <a:r>
-                        <a:rPr sz="1200">
+                        <a:rPr sz="1100">
                           <a:latin typeface="Times New Roman"/>
                         </a:rPr>
                         <a:t>13</a:t>
@@ -4997,7 +5183,7 @@
                     <a:lstStyle/>
                     <a:p>
                       <a:r>
-                        <a:rPr sz="1200">
+                        <a:rPr sz="1100">
                           <a:latin typeface="Times New Roman"/>
                         </a:rPr>
                         <a:t>17</a:t>
@@ -5012,12 +5198,35 @@
                     <a:lstStyle/>
                     <a:p>
                       <a:r>
-                        <a:rPr sz="1200">
+                        <a:rPr sz="1100">
                           <a:latin typeface="Times New Roman"/>
                         </a:rPr>
                         <a:t>42</a:t>
                       </a:r>
                     </a:p>
+                  </a:txBody>
+                  <a:tcPr/>
+                </a:tc>
+                <a:tc>
+                  <a:txBody>
+                    <a:bodyPr/>
+                    <a:lstStyle/>
+                    <a:p>
+                      <a:r>
+                        <a:rPr sz="1100">
+                          <a:latin typeface="Times New Roman"/>
+                        </a:rPr>
+                        <a:t>2 (2)</a:t>
+                      </a:r>
+                    </a:p>
+                  </a:txBody>
+                  <a:tcPr/>
+                </a:tc>
+                <a:tc>
+                  <a:txBody>
+                    <a:bodyPr/>
+                    <a:lstStyle/>
+                    <a:p/>
                   </a:txBody>
                   <a:tcPr/>
                 </a:tc>
@@ -5029,7 +5238,7 @@
                     <a:lstStyle/>
                     <a:p>
                       <a:r>
-                        <a:rPr sz="1200">
+                        <a:rPr sz="1100">
                           <a:latin typeface="Times New Roman"/>
                         </a:rPr>
                         <a:t>FT09-07018</a:t>
@@ -5044,7 +5253,7 @@
                     <a:lstStyle/>
                     <a:p>
                       <a:r>
-                        <a:rPr sz="1200">
+                        <a:rPr sz="1100">
                           <a:latin typeface="Times New Roman"/>
                         </a:rPr>
                         <a:t>8.4</a:t>
@@ -5059,7 +5268,7 @@
                     <a:lstStyle/>
                     <a:p>
                       <a:r>
-                        <a:rPr sz="1200">
+                        <a:rPr sz="1100">
                           <a:latin typeface="Times New Roman"/>
                         </a:rPr>
                         <a:t>5.7</a:t>
@@ -5074,7 +5283,7 @@
                     <a:lstStyle/>
                     <a:p>
                       <a:r>
-                        <a:rPr sz="1200">
+                        <a:rPr sz="1100">
                           <a:latin typeface="Times New Roman"/>
                         </a:rPr>
                         <a:t>9.0</a:t>
@@ -5089,7 +5298,7 @@
                     <a:lstStyle/>
                     <a:p>
                       <a:r>
-                        <a:rPr sz="1200">
+                        <a:rPr sz="1100">
                           <a:latin typeface="Times New Roman"/>
                         </a:rPr>
                         <a:t>7.5</a:t>
@@ -5104,12 +5313,35 @@
                     <a:lstStyle/>
                     <a:p>
                       <a:r>
-                        <a:rPr sz="1200">
+                        <a:rPr sz="1100">
                           <a:latin typeface="Times New Roman"/>
                         </a:rPr>
                         <a:t>53</a:t>
                       </a:r>
                     </a:p>
+                  </a:txBody>
+                  <a:tcPr/>
+                </a:tc>
+                <a:tc>
+                  <a:txBody>
+                    <a:bodyPr/>
+                    <a:lstStyle/>
+                    <a:p>
+                      <a:r>
+                        <a:rPr sz="1100">
+                          <a:latin typeface="Times New Roman"/>
+                        </a:rPr>
+                        <a:t>3 (3)</a:t>
+                      </a:r>
+                    </a:p>
+                  </a:txBody>
+                  <a:tcPr/>
+                </a:tc>
+                <a:tc>
+                  <a:txBody>
+                    <a:bodyPr/>
+                    <a:lstStyle/>
+                    <a:p/>
                   </a:txBody>
                   <a:tcPr/>
                 </a:tc>
@@ -5121,7 +5353,7 @@
                     <a:lstStyle/>
                     <a:p>
                       <a:r>
-                        <a:rPr sz="1200">
+                        <a:rPr sz="1100">
                           <a:latin typeface="Times New Roman"/>
                         </a:rPr>
                         <a:t>FT09-07022</a:t>
@@ -5136,7 +5368,7 @@
                     <a:lstStyle/>
                     <a:p>
                       <a:r>
-                        <a:rPr sz="1200">
+                        <a:rPr sz="1100">
                           <a:latin typeface="Times New Roman"/>
                         </a:rPr>
                         <a:t>9.6</a:t>
@@ -5151,7 +5383,7 @@
                     <a:lstStyle/>
                     <a:p>
                       <a:r>
-                        <a:rPr sz="1200">
+                        <a:rPr sz="1100">
                           <a:latin typeface="Times New Roman"/>
                         </a:rPr>
                         <a:t>12</a:t>
@@ -5174,7 +5406,7 @@
                     <a:lstStyle/>
                     <a:p>
                       <a:r>
-                        <a:rPr sz="1200">
+                        <a:rPr sz="1100">
                           <a:latin typeface="Times New Roman"/>
                         </a:rPr>
                         <a:t>11</a:t>
@@ -5189,12 +5421,35 @@
                     <a:lstStyle/>
                     <a:p>
                       <a:r>
-                        <a:rPr sz="1200">
+                        <a:rPr sz="1100">
                           <a:latin typeface="Times New Roman"/>
                         </a:rPr>
                         <a:t>41</a:t>
                       </a:r>
                     </a:p>
+                  </a:txBody>
+                  <a:tcPr/>
+                </a:tc>
+                <a:tc>
+                  <a:txBody>
+                    <a:bodyPr/>
+                    <a:lstStyle/>
+                    <a:p>
+                      <a:r>
+                        <a:rPr sz="1100">
+                          <a:latin typeface="Times New Roman"/>
+                        </a:rPr>
+                        <a:t>2 (2)</a:t>
+                      </a:r>
+                    </a:p>
+                  </a:txBody>
+                  <a:tcPr/>
+                </a:tc>
+                <a:tc>
+                  <a:txBody>
+                    <a:bodyPr/>
+                    <a:lstStyle/>
+                    <a:p/>
                   </a:txBody>
                   <a:tcPr/>
                 </a:tc>
@@ -5206,7 +5461,7 @@
                     <a:lstStyle/>
                     <a:p>
                       <a:r>
-                        <a:rPr sz="1200">
+                        <a:rPr sz="1100">
                           <a:latin typeface="Times New Roman"/>
                         </a:rPr>
                         <a:t>FT09-07034</a:t>
@@ -5221,7 +5476,7 @@
                     <a:lstStyle/>
                     <a:p>
                       <a:r>
-                        <a:rPr sz="1200">
+                        <a:rPr sz="1100">
                           <a:latin typeface="Times New Roman"/>
                         </a:rPr>
                         <a:t>&gt;30</a:t>
@@ -5236,7 +5491,7 @@
                     <a:lstStyle/>
                     <a:p>
                       <a:r>
-                        <a:rPr sz="1200">
+                        <a:rPr sz="1100">
                           <a:latin typeface="Times New Roman"/>
                         </a:rPr>
                         <a:t>20</a:t>
@@ -5259,7 +5514,7 @@
                     <a:lstStyle/>
                     <a:p>
                       <a:r>
-                        <a:rPr sz="1200">
+                        <a:rPr sz="1100">
                           <a:latin typeface="Times New Roman"/>
                         </a:rPr>
                         <a:t>&gt;30</a:t>
@@ -5274,12 +5529,35 @@
                     <a:lstStyle/>
                     <a:p>
                       <a:r>
-                        <a:rPr sz="1200">
+                        <a:rPr sz="1100">
                           <a:latin typeface="Times New Roman"/>
                         </a:rPr>
                         <a:t>25</a:t>
                       </a:r>
                     </a:p>
+                  </a:txBody>
+                  <a:tcPr/>
+                </a:tc>
+                <a:tc>
+                  <a:txBody>
+                    <a:bodyPr/>
+                    <a:lstStyle/>
+                    <a:p>
+                      <a:r>
+                        <a:rPr sz="1100">
+                          <a:latin typeface="Times New Roman"/>
+                        </a:rPr>
+                        <a:t>2 (1)</a:t>
+                      </a:r>
+                    </a:p>
+                  </a:txBody>
+                  <a:tcPr/>
+                </a:tc>
+                <a:tc>
+                  <a:txBody>
+                    <a:bodyPr/>
+                    <a:lstStyle/>
+                    <a:p/>
                   </a:txBody>
                   <a:tcPr/>
                 </a:tc>
@@ -5291,7 +5569,7 @@
                     <a:lstStyle/>
                     <a:p>
                       <a:r>
-                        <a:rPr sz="1200">
+                        <a:rPr sz="1100">
                           <a:latin typeface="Times New Roman"/>
                         </a:rPr>
                         <a:t>FT09-07036</a:t>
@@ -5306,7 +5584,7 @@
                     <a:lstStyle/>
                     <a:p>
                       <a:r>
-                        <a:rPr sz="1200">
+                        <a:rPr sz="1100">
                           <a:latin typeface="Times New Roman"/>
                         </a:rPr>
                         <a:t>15</a:t>
@@ -5321,7 +5599,7 @@
                     <a:lstStyle/>
                     <a:p>
                       <a:r>
-                        <a:rPr sz="1200">
+                        <a:rPr sz="1100">
                           <a:latin typeface="Times New Roman"/>
                         </a:rPr>
                         <a:t>25</a:t>
@@ -5344,7 +5622,7 @@
                     <a:lstStyle/>
                     <a:p>
                       <a:r>
-                        <a:rPr sz="1200">
+                        <a:rPr sz="1100">
                           <a:latin typeface="Times New Roman"/>
                         </a:rPr>
                         <a:t>20</a:t>
@@ -5359,12 +5637,35 @@
                     <a:lstStyle/>
                     <a:p>
                       <a:r>
-                        <a:rPr sz="1200">
+                        <a:rPr sz="1100">
                           <a:latin typeface="Times New Roman"/>
                         </a:rPr>
                         <a:t>33</a:t>
                       </a:r>
                     </a:p>
+                  </a:txBody>
+                  <a:tcPr/>
+                </a:tc>
+                <a:tc>
+                  <a:txBody>
+                    <a:bodyPr/>
+                    <a:lstStyle/>
+                    <a:p>
+                      <a:r>
+                        <a:rPr sz="1100">
+                          <a:latin typeface="Times New Roman"/>
+                        </a:rPr>
+                        <a:t>2 (2)</a:t>
+                      </a:r>
+                    </a:p>
+                  </a:txBody>
+                  <a:tcPr/>
+                </a:tc>
+                <a:tc>
+                  <a:txBody>
+                    <a:bodyPr/>
+                    <a:lstStyle/>
+                    <a:p/>
                   </a:txBody>
                   <a:tcPr/>
                 </a:tc>
@@ -5376,7 +5677,7 @@
                     <a:lstStyle/>
                     <a:p>
                       <a:r>
-                        <a:rPr sz="1200">
+                        <a:rPr sz="1100">
                           <a:latin typeface="Times New Roman"/>
                         </a:rPr>
                         <a:t>FT09-07040</a:t>
@@ -5391,7 +5692,7 @@
                     <a:lstStyle/>
                     <a:p>
                       <a:r>
-                        <a:rPr sz="1200">
+                        <a:rPr sz="1100">
                           <a:latin typeface="Times New Roman"/>
                         </a:rPr>
                         <a:t>19</a:t>
@@ -5406,7 +5707,7 @@
                     <a:lstStyle/>
                     <a:p>
                       <a:r>
-                        <a:rPr sz="1200">
+                        <a:rPr sz="1100">
                           <a:latin typeface="Times New Roman"/>
                         </a:rPr>
                         <a:t>&gt;30</a:t>
@@ -5429,7 +5730,7 @@
                     <a:lstStyle/>
                     <a:p>
                       <a:r>
-                        <a:rPr sz="1200">
+                        <a:rPr sz="1100">
                           <a:latin typeface="Times New Roman"/>
                         </a:rPr>
                         <a:t>&gt;30</a:t>
@@ -5444,12 +5745,35 @@
                     <a:lstStyle/>
                     <a:p>
                       <a:r>
-                        <a:rPr sz="1200">
+                        <a:rPr sz="1100">
                           <a:latin typeface="Times New Roman"/>
                         </a:rPr>
                         <a:t>29</a:t>
                       </a:r>
                     </a:p>
+                  </a:txBody>
+                  <a:tcPr/>
+                </a:tc>
+                <a:tc>
+                  <a:txBody>
+                    <a:bodyPr/>
+                    <a:lstStyle/>
+                    <a:p>
+                      <a:r>
+                        <a:rPr sz="1100">
+                          <a:latin typeface="Times New Roman"/>
+                        </a:rPr>
+                        <a:t>2 (1)</a:t>
+                      </a:r>
+                    </a:p>
+                  </a:txBody>
+                  <a:tcPr/>
+                </a:tc>
+                <a:tc>
+                  <a:txBody>
+                    <a:bodyPr/>
+                    <a:lstStyle/>
+                    <a:p/>
                   </a:txBody>
                   <a:tcPr/>
                 </a:tc>
@@ -5461,7 +5785,7 @@
                     <a:lstStyle/>
                     <a:p>
                       <a:r>
-                        <a:rPr sz="1200">
+                        <a:rPr sz="1100">
                           <a:latin typeface="Times New Roman"/>
                         </a:rPr>
                         <a:t>FT09-07046</a:t>
@@ -5476,7 +5800,7 @@
                     <a:lstStyle/>
                     <a:p>
                       <a:r>
-                        <a:rPr sz="1200">
+                        <a:rPr sz="1100">
                           <a:latin typeface="Times New Roman"/>
                         </a:rPr>
                         <a:t>19</a:t>
@@ -5491,7 +5815,7 @@
                     <a:lstStyle/>
                     <a:p>
                       <a:r>
-                        <a:rPr sz="1200">
+                        <a:rPr sz="1100">
                           <a:latin typeface="Times New Roman"/>
                         </a:rPr>
                         <a:t>15</a:t>
@@ -5514,7 +5838,7 @@
                     <a:lstStyle/>
                     <a:p>
                       <a:r>
-                        <a:rPr sz="1200">
+                        <a:rPr sz="1100">
                           <a:latin typeface="Times New Roman"/>
                         </a:rPr>
                         <a:t>17</a:t>
@@ -5529,12 +5853,35 @@
                     <a:lstStyle/>
                     <a:p>
                       <a:r>
-                        <a:rPr sz="1200">
+                        <a:rPr sz="1100">
                           <a:latin typeface="Times New Roman"/>
                         </a:rPr>
                         <a:t>33</a:t>
                       </a:r>
                     </a:p>
+                  </a:txBody>
+                  <a:tcPr/>
+                </a:tc>
+                <a:tc>
+                  <a:txBody>
+                    <a:bodyPr/>
+                    <a:lstStyle/>
+                    <a:p>
+                      <a:r>
+                        <a:rPr sz="1100">
+                          <a:latin typeface="Times New Roman"/>
+                        </a:rPr>
+                        <a:t>2 (2)</a:t>
+                      </a:r>
+                    </a:p>
+                  </a:txBody>
+                  <a:tcPr/>
+                </a:tc>
+                <a:tc>
+                  <a:txBody>
+                    <a:bodyPr/>
+                    <a:lstStyle/>
+                    <a:p/>
                   </a:txBody>
                   <a:tcPr/>
                 </a:tc>
@@ -5546,7 +5893,7 @@
                     <a:lstStyle/>
                     <a:p>
                       <a:r>
-                        <a:rPr sz="1200">
+                        <a:rPr sz="1100">
                           <a:latin typeface="Times New Roman"/>
                         </a:rPr>
                         <a:t>FT09-07060</a:t>
@@ -5561,7 +5908,7 @@
                     <a:lstStyle/>
                     <a:p>
                       <a:r>
-                        <a:rPr sz="1200">
+                        <a:rPr sz="1100">
                           <a:latin typeface="Times New Roman"/>
                         </a:rPr>
                         <a:t>12</a:t>
@@ -5576,7 +5923,7 @@
                     <a:lstStyle/>
                     <a:p>
                       <a:r>
-                        <a:rPr sz="1200">
+                        <a:rPr sz="1100">
                           <a:latin typeface="Times New Roman"/>
                         </a:rPr>
                         <a:t>11</a:t>
@@ -5599,7 +5946,7 @@
                     <a:lstStyle/>
                     <a:p>
                       <a:r>
-                        <a:rPr sz="1200">
+                        <a:rPr sz="1100">
                           <a:latin typeface="Times New Roman"/>
                         </a:rPr>
                         <a:t>12</a:t>
@@ -5614,12 +5961,35 @@
                     <a:lstStyle/>
                     <a:p>
                       <a:r>
-                        <a:rPr sz="1200">
+                        <a:rPr sz="1100">
                           <a:latin typeface="Times New Roman"/>
                         </a:rPr>
                         <a:t>48</a:t>
                       </a:r>
                     </a:p>
+                  </a:txBody>
+                  <a:tcPr/>
+                </a:tc>
+                <a:tc>
+                  <a:txBody>
+                    <a:bodyPr/>
+                    <a:lstStyle/>
+                    <a:p>
+                      <a:r>
+                        <a:rPr sz="1100">
+                          <a:latin typeface="Times New Roman"/>
+                        </a:rPr>
+                        <a:t>2 (2)</a:t>
+                      </a:r>
+                    </a:p>
+                  </a:txBody>
+                  <a:tcPr/>
+                </a:tc>
+                <a:tc>
+                  <a:txBody>
+                    <a:bodyPr/>
+                    <a:lstStyle/>
+                    <a:p/>
                   </a:txBody>
                   <a:tcPr/>
                 </a:tc>
@@ -5631,7 +6001,7 @@
                     <a:lstStyle/>
                     <a:p>
                       <a:r>
-                        <a:rPr sz="1200">
+                        <a:rPr sz="1100">
                           <a:latin typeface="Times New Roman"/>
                         </a:rPr>
                         <a:t>FT09-07076</a:t>
@@ -5646,7 +6016,7 @@
                     <a:lstStyle/>
                     <a:p>
                       <a:r>
-                        <a:rPr sz="1200">
+                        <a:rPr sz="1100">
                           <a:latin typeface="Times New Roman"/>
                         </a:rPr>
                         <a:t>6.3</a:t>
@@ -5661,7 +6031,7 @@
                     <a:lstStyle/>
                     <a:p>
                       <a:r>
-                        <a:rPr sz="1200">
+                        <a:rPr sz="1100">
                           <a:latin typeface="Times New Roman"/>
                         </a:rPr>
                         <a:t>5.3</a:t>
@@ -5684,7 +6054,7 @@
                     <a:lstStyle/>
                     <a:p>
                       <a:r>
-                        <a:rPr sz="1200">
+                        <a:rPr sz="1100">
                           <a:latin typeface="Times New Roman"/>
                         </a:rPr>
                         <a:t>5.8</a:t>
@@ -5699,12 +6069,35 @@
                     <a:lstStyle/>
                     <a:p>
                       <a:r>
-                        <a:rPr sz="1200">
+                        <a:rPr sz="1100">
                           <a:latin typeface="Times New Roman"/>
                         </a:rPr>
                         <a:t>59</a:t>
                       </a:r>
                     </a:p>
+                  </a:txBody>
+                  <a:tcPr/>
+                </a:tc>
+                <a:tc>
+                  <a:txBody>
+                    <a:bodyPr/>
+                    <a:lstStyle/>
+                    <a:p>
+                      <a:r>
+                        <a:rPr sz="1100">
+                          <a:latin typeface="Times New Roman"/>
+                        </a:rPr>
+                        <a:t>2 (2)</a:t>
+                      </a:r>
+                    </a:p>
+                  </a:txBody>
+                  <a:tcPr/>
+                </a:tc>
+                <a:tc>
+                  <a:txBody>
+                    <a:bodyPr/>
+                    <a:lstStyle/>
+                    <a:p/>
                   </a:txBody>
                   <a:tcPr/>
                 </a:tc>
@@ -5716,7 +6109,7 @@
                     <a:lstStyle/>
                     <a:p>
                       <a:r>
-                        <a:rPr sz="1200">
+                        <a:rPr sz="1100">
                           <a:latin typeface="Times New Roman"/>
                         </a:rPr>
                         <a:t>FT09-07078</a:t>
@@ -5731,7 +6124,7 @@
                     <a:lstStyle/>
                     <a:p>
                       <a:r>
-                        <a:rPr sz="1200">
+                        <a:rPr sz="1100">
                           <a:latin typeface="Times New Roman"/>
                         </a:rPr>
                         <a:t>10.0</a:t>
@@ -5746,7 +6139,7 @@
                     <a:lstStyle/>
                     <a:p>
                       <a:r>
-                        <a:rPr sz="1200">
+                        <a:rPr sz="1100">
                           <a:latin typeface="Times New Roman"/>
                         </a:rPr>
                         <a:t>7.9</a:t>
@@ -5761,7 +6154,7 @@
                     <a:lstStyle/>
                     <a:p>
                       <a:r>
-                        <a:rPr sz="1200">
+                        <a:rPr sz="1100">
                           <a:latin typeface="Times New Roman"/>
                         </a:rPr>
                         <a:t>6.6</a:t>
@@ -5776,7 +6169,7 @@
                     <a:lstStyle/>
                     <a:p>
                       <a:r>
-                        <a:rPr sz="1200">
+                        <a:rPr sz="1100">
                           <a:latin typeface="Times New Roman"/>
                         </a:rPr>
                         <a:t>8.0</a:t>
@@ -5791,12 +6184,35 @@
                     <a:lstStyle/>
                     <a:p>
                       <a:r>
-                        <a:rPr sz="1200">
+                        <a:rPr sz="1100">
                           <a:latin typeface="Times New Roman"/>
                         </a:rPr>
                         <a:t>54</a:t>
                       </a:r>
                     </a:p>
+                  </a:txBody>
+                  <a:tcPr/>
+                </a:tc>
+                <a:tc>
+                  <a:txBody>
+                    <a:bodyPr/>
+                    <a:lstStyle/>
+                    <a:p>
+                      <a:r>
+                        <a:rPr sz="1100">
+                          <a:latin typeface="Times New Roman"/>
+                        </a:rPr>
+                        <a:t>3 (3)</a:t>
+                      </a:r>
+                    </a:p>
+                  </a:txBody>
+                  <a:tcPr/>
+                </a:tc>
+                <a:tc>
+                  <a:txBody>
+                    <a:bodyPr/>
+                    <a:lstStyle/>
+                    <a:p/>
                   </a:txBody>
                   <a:tcPr/>
                 </a:tc>
@@ -5808,7 +6224,7 @@
                     <a:lstStyle/>
                     <a:p>
                       <a:r>
-                        <a:rPr sz="1200">
+                        <a:rPr sz="1100">
                           <a:latin typeface="Times New Roman"/>
                         </a:rPr>
                         <a:t>FT09-07082</a:t>
@@ -5823,7 +6239,7 @@
                     <a:lstStyle/>
                     <a:p>
                       <a:r>
-                        <a:rPr sz="1200">
+                        <a:rPr sz="1100">
                           <a:latin typeface="Times New Roman"/>
                         </a:rPr>
                         <a:t>3.1</a:t>
@@ -5838,7 +6254,7 @@
                     <a:lstStyle/>
                     <a:p>
                       <a:r>
-                        <a:rPr sz="1200">
+                        <a:rPr sz="1100">
                           <a:latin typeface="Times New Roman"/>
                         </a:rPr>
                         <a:t>2.6</a:t>
@@ -5861,7 +6277,7 @@
                     <a:lstStyle/>
                     <a:p>
                       <a:r>
-                        <a:rPr sz="1200">
+                        <a:rPr sz="1100">
                           <a:latin typeface="Times New Roman"/>
                         </a:rPr>
                         <a:t>2.8</a:t>
@@ -5876,12 +6292,35 @@
                     <a:lstStyle/>
                     <a:p>
                       <a:r>
-                        <a:rPr sz="1200">
+                        <a:rPr sz="1100">
                           <a:latin typeface="Times New Roman"/>
                         </a:rPr>
                         <a:t>77</a:t>
                       </a:r>
                     </a:p>
+                  </a:txBody>
+                  <a:tcPr/>
+                </a:tc>
+                <a:tc>
+                  <a:txBody>
+                    <a:bodyPr/>
+                    <a:lstStyle/>
+                    <a:p>
+                      <a:r>
+                        <a:rPr sz="1100">
+                          <a:latin typeface="Times New Roman"/>
+                        </a:rPr>
+                        <a:t>2 (2)</a:t>
+                      </a:r>
+                    </a:p>
+                  </a:txBody>
+                  <a:tcPr/>
+                </a:tc>
+                <a:tc>
+                  <a:txBody>
+                    <a:bodyPr/>
+                    <a:lstStyle/>
+                    <a:p/>
                   </a:txBody>
                   <a:tcPr/>
                 </a:tc>
@@ -5893,7 +6332,7 @@
                     <a:lstStyle/>
                     <a:p>
                       <a:r>
-                        <a:rPr sz="1200">
+                        <a:rPr sz="1100">
                           <a:latin typeface="Times New Roman"/>
                         </a:rPr>
                         <a:t>FT09-07084</a:t>
@@ -5908,7 +6347,7 @@
                     <a:lstStyle/>
                     <a:p>
                       <a:r>
-                        <a:rPr sz="1200">
+                        <a:rPr sz="1100">
                           <a:latin typeface="Times New Roman"/>
                         </a:rPr>
                         <a:t>18</a:t>
@@ -5923,7 +6362,7 @@
                     <a:lstStyle/>
                     <a:p>
                       <a:r>
-                        <a:rPr sz="1200">
+                        <a:rPr sz="1100">
                           <a:latin typeface="Times New Roman"/>
                         </a:rPr>
                         <a:t>12</a:t>
@@ -5946,7 +6385,7 @@
                     <a:lstStyle/>
                     <a:p>
                       <a:r>
-                        <a:rPr sz="1200">
+                        <a:rPr sz="1100">
                           <a:latin typeface="Times New Roman"/>
                         </a:rPr>
                         <a:t>15</a:t>
@@ -5961,12 +6400,35 @@
                     <a:lstStyle/>
                     <a:p>
                       <a:r>
-                        <a:rPr sz="1200">
+                        <a:rPr sz="1100">
                           <a:latin typeface="Times New Roman"/>
                         </a:rPr>
                         <a:t>38</a:t>
                       </a:r>
                     </a:p>
+                  </a:txBody>
+                  <a:tcPr/>
+                </a:tc>
+                <a:tc>
+                  <a:txBody>
+                    <a:bodyPr/>
+                    <a:lstStyle/>
+                    <a:p>
+                      <a:r>
+                        <a:rPr sz="1100">
+                          <a:latin typeface="Times New Roman"/>
+                        </a:rPr>
+                        <a:t>2 (2)</a:t>
+                      </a:r>
+                    </a:p>
+                  </a:txBody>
+                  <a:tcPr/>
+                </a:tc>
+                <a:tc>
+                  <a:txBody>
+                    <a:bodyPr/>
+                    <a:lstStyle/>
+                    <a:p/>
                   </a:txBody>
                   <a:tcPr/>
                 </a:tc>
@@ -6239,7 +6701,7 @@
               <a:rPr sz="2000">
                 <a:latin typeface="Times New Roman"/>
               </a:rPr>
-              <a:t>E-4031 reference gave a control IC50 of 16 nM</a:t>
+              <a:t>E-4031 reference gave a control IC50 of 16 nM, within the protocol acceptance window</a:t>
             </a:r>
           </a:p>
           <a:p>
@@ -6248,16 +6710,7 @@
               <a:rPr sz="2000">
                 <a:latin typeface="Times New Roman"/>
               </a:rPr>
-              <a:t>Control acceptance was signed off on the run sheet before compound data were read</a:t>
-            </a:r>
-          </a:p>
-          <a:p>
-            <a:pPr lvl="1"/>
-            <a:r>
-              <a:rPr sz="1700">
-                <a:latin typeface="Times New Roman"/>
-              </a:rPr>
-              <a:t>Ines Alvarado checked the acceptance record against the sample cards</a:t>
+              <a:t>Compound IC50 is the geometric mean of finite cell estimates only when finite estimates are the majority of accepted cells</a:t>
             </a:r>
           </a:p>
           <a:p>
@@ -6266,7 +6719,16 @@
               <a:rPr sz="2000">
                 <a:latin typeface="Times New Roman"/>
               </a:rPr>
-              <a:t>4 estimates are censored and carry their qualification in the table</a:t>
+              <a:t>Otherwise the compound estimate is censored at the applicable tested limit</a:t>
+            </a:r>
+          </a:p>
+          <a:p>
+            <a:pPr/>
+            <a:r>
+              <a:rPr sz="2000">
+                <a:latin typeface="Times New Roman"/>
+              </a:rPr>
+              <a:t>4 compound estimates are censored; cell counts and qualifications remain in the table</a:t>
             </a:r>
           </a:p>
           <a:p>
@@ -6435,7 +6897,7 @@
               <a:rPr sz="1800">
                 <a:latin typeface="Times New Roman"/>
               </a:rPr>
-              <a:t>Strongly basic side chain drives the hERG inhibition in this series</a:t>
+              <a:t>Feldorune dropped the most strongly basic side chain after reproducible hERG inhibition in the confirmatory run</a:t>
             </a:r>
           </a:p>
           <a:p>
@@ -6444,7 +6906,7 @@
               <a:rPr sz="1800">
                 <a:latin typeface="Times New Roman"/>
               </a:rPr>
-              <a:t>Reproducible in the confirmatory run</a:t>
+              <a:t>This supports the chemistry selection decision; the table alone does not establish side-chain causality</a:t>
             </a:r>
           </a:p>
         </p:txBody>
@@ -6476,7 +6938,7 @@
               <a:rPr sz="1800">
                 <a:latin typeface="Times New Roman"/>
               </a:rPr>
-              <a:t>Feldorune has dropped the side chain from the next synthesis</a:t>
+              <a:t>Other members of the screening set also inhibit hERG</a:t>
             </a:r>
           </a:p>
           <a:p>
@@ -6485,7 +6947,7 @@
               <a:rPr sz="1800">
                 <a:latin typeface="Times New Roman"/>
               </a:rPr>
-              <a:t>Screening result is kept separate from any mechanism</a:t>
+              <a:t>Keep the screening decision separate from a mechanistic or clinical safety claim</a:t>
             </a:r>
           </a:p>
         </p:txBody>
@@ -6613,82 +7075,14 @@
                 </a:solidFill>
                 <a:latin typeface="Arial"/>
               </a:rPr>
-              <a:t>Timeline</a:t>
-            </a:r>
-          </a:p>
-        </p:txBody>
-      </p:sp>
-      <p:sp>
-        <p:nvSpPr>
-          <p:cNvPr id="3" name="Content Placeholder 2"/>
-          <p:cNvSpPr>
-            <a:spLocks noGrp="1"/>
-          </p:cNvSpPr>
-          <p:nvPr>
-            <p:ph idx="1"/>
-          </p:nvPr>
-        </p:nvSpPr>
-        <p:spPr>
-          <a:xfrm>
-            <a:off x="457200" y="1280160"/>
-            <a:ext cx="11277295" cy="4937760"/>
-          </a:xfrm>
-        </p:spPr>
-        <p:txBody>
-          <a:bodyPr wrap="square">
-            <a:noAutofit/>
-          </a:bodyPr>
-          <a:lstStyle/>
-          <a:p>
-            <a:pPr/>
-            <a:r>
-              <a:rPr sz="2000">
-                <a:latin typeface="Times New Roman"/>
-              </a:rPr>
-              <a:t>Quote accepted 06 Jun 2018</a:t>
-            </a:r>
-          </a:p>
-          <a:p>
-            <a:pPr/>
-            <a:r>
-              <a:rPr sz="2000">
-                <a:latin typeface="Times New Roman"/>
-              </a:rPr>
-              <a:t>Study started 06 Jul 2018</a:t>
-            </a:r>
-          </a:p>
-          <a:p>
-            <a:pPr/>
-            <a:r>
-              <a:rPr sz="2000">
-                <a:latin typeface="Times New Roman"/>
-              </a:rPr>
-              <a:t>Interim position issued 16 Jul 2018</a:t>
-            </a:r>
-          </a:p>
-          <a:p>
-            <a:pPr/>
-            <a:r>
-              <a:rPr sz="2000">
-                <a:latin typeface="Times New Roman"/>
-              </a:rPr>
-              <a:t>Completed and issued 23 Jul 2018</a:t>
-            </a:r>
-          </a:p>
-          <a:p>
-            <a:pPr lvl="1"/>
-            <a:r>
-              <a:rPr sz="1700">
-                <a:latin typeface="Times New Roman"/>
-              </a:rPr>
-              <a:t>Turnaround 17 days</a:t>
-            </a:r>
-          </a:p>
-        </p:txBody>
-      </p:sp>
-      <p:sp>
-        <p:nvSpPr>
-          <p:cNvPr id="4" name="Rectangle 3"/>
+              <a:t>FT09 indazole screening set</a:t>
+            </a:r>
+          </a:p>
+        </p:txBody>
+      </p:sp>
+      <p:sp>
+        <p:nvSpPr>
+          <p:cNvPr id="3" name="Rectangle 2"/>
           <p:cNvSpPr/>
           <p:nvPr/>
         </p:nvSpPr>
@@ -6729,6 +7123,30 @@
           </a:p>
         </p:txBody>
       </p:sp>
+      <p:pic>
+        <p:nvPicPr>
+          <p:cNvPr id="4" name="Picture 3" descr="image.png"/>
+          <p:cNvPicPr>
+            <a:picLocks noChangeAspect="1"/>
+          </p:cNvPicPr>
+          <p:nvPr/>
+        </p:nvPicPr>
+        <p:blipFill>
+          <a:blip r:embed="rId2"/>
+          <a:stretch>
+            <a:fillRect/>
+          </a:stretch>
+        </p:blipFill>
+        <p:spPr>
+          <a:xfrm>
+            <a:off x="457200" y="1280160"/>
+            <a:ext cx="11277295" cy="4337421"/>
+          </a:xfrm>
+          <a:prstGeom prst="rect">
+            <a:avLst/>
+          </a:prstGeom>
+        </p:spPr>
+      </p:pic>
       <p:sp>
         <p:nvSpPr>
           <p:cNvPr id="5" name="TextBox 4"/>

</xml_diff>